<commit_message>
Perbarui dokumentasi dan laporan pengujian untuk mencerminkan perubahan terbaru. Tambahkan informasi tentang jumlah pengujian dan pernyataan yang lulus, serta perbarui panduan penggunaan dan sistem alur untuk mencakup fitur baru seperti pengaturan urutan jam pelajaran melalui drag-and-drop. Perbaiki detail pada laporan pengerjaan akhir dan perbarui format panduan untuk meningkatkan kejelasan dan aksesibilitas. Selain itu, perbarui screenshot untuk mencerminkan antarmuka terbaru.
</commit_message>
<xml_diff>
--- a/docs/presentasi-aplikasi-sisd232.pptx
+++ b/docs/presentasi-aplikasi-sisd232.pptx
@@ -3651,8 +3651,8 @@
         </p:blipFill>
         <p:spPr>
           <a:xfrm>
-            <a:off x="841248" y="2122551"/>
-            <a:ext cx="5074920" cy="3637025"/>
+            <a:off x="855061" y="1965960"/>
+            <a:ext cx="5047293" cy="3950208"/>
           </a:xfrm>
           <a:prstGeom prst="rect">
             <a:avLst/>
@@ -3720,8 +3720,8 @@
         </p:blipFill>
         <p:spPr>
           <a:xfrm>
-            <a:off x="6510528" y="2258314"/>
-            <a:ext cx="4846320" cy="3365500"/>
+            <a:off x="6510528" y="2185955"/>
+            <a:ext cx="4846320" cy="3510216"/>
           </a:xfrm>
           <a:prstGeom prst="rect">
             <a:avLst/>
@@ -4111,8 +4111,8 @@
         </p:blipFill>
         <p:spPr>
           <a:xfrm>
-            <a:off x="2048357" y="1920240"/>
-            <a:ext cx="4452925" cy="4041648"/>
+            <a:off x="3164138" y="1920240"/>
+            <a:ext cx="2221363" cy="4041648"/>
           </a:xfrm>
           <a:prstGeom prst="rect">
             <a:avLst/>
@@ -4521,8 +4521,8 @@
         </p:blipFill>
         <p:spPr>
           <a:xfrm>
-            <a:off x="944062" y="1920240"/>
-            <a:ext cx="4878435" cy="4041648"/>
+            <a:off x="1496129" y="1920240"/>
+            <a:ext cx="3774301" cy="4041648"/>
           </a:xfrm>
           <a:prstGeom prst="rect">
             <a:avLst/>
@@ -4590,8 +4590,8 @@
         </p:blipFill>
         <p:spPr>
           <a:xfrm>
-            <a:off x="6622122" y="1920240"/>
-            <a:ext cx="4659706" cy="4041648"/>
+            <a:off x="7074565" y="1920240"/>
+            <a:ext cx="3754821" cy="4041648"/>
           </a:xfrm>
           <a:prstGeom prst="rect">
             <a:avLst/>
@@ -4981,8 +4981,8 @@
         </p:blipFill>
         <p:spPr>
           <a:xfrm>
-            <a:off x="1751590" y="1901952"/>
-            <a:ext cx="1343139" cy="3950208"/>
+            <a:off x="1510493" y="1901952"/>
+            <a:ext cx="1825333" cy="3950208"/>
           </a:xfrm>
           <a:prstGeom prst="rect">
             <a:avLst/>
@@ -5088,7 +5088,7 @@
       </p:sp>
       <p:pic>
         <p:nvPicPr>
-          <p:cNvPr id="9" name="Picture 8" descr="mobile-guru-input-nilai-terisi.png"/>
+          <p:cNvPr id="9" name="Picture 8" descr="mobile-admin-siswa.png"/>
           <p:cNvPicPr>
             <a:picLocks noChangeAspect="1"/>
           </p:cNvPicPr>
@@ -5102,8 +5102,8 @@
         </p:blipFill>
         <p:spPr>
           <a:xfrm>
-            <a:off x="5275330" y="1901952"/>
-            <a:ext cx="1702299" cy="3950208"/>
+            <a:off x="5213813" y="1901952"/>
+            <a:ext cx="1825333" cy="3950208"/>
           </a:xfrm>
           <a:prstGeom prst="rect">
             <a:avLst/>
@@ -5157,7 +5157,7 @@
                 </a:solidFill>
                 <a:latin typeface="Aptos"/>
               </a:rPr>
-              <a:t>INPUT NILAI</a:t>
+              <a:t>TABEL ADMIN</a:t>
             </a:r>
           </a:p>
         </p:txBody>
@@ -6186,7 +6186,7 @@
                 </a:solidFill>
                 <a:latin typeface="Aptos"/>
               </a:rPr>
-              <a:t>18 test dan 76 assertion memastikan aturan penting berjalan.</a:t>
+              <a:t>51 test dan 371 assertion memastikan aturan penting berjalan.</a:t>
             </a:r>
           </a:p>
         </p:txBody>
@@ -6417,8 +6417,8 @@
         </p:nvSpPr>
         <p:spPr>
           <a:xfrm>
-            <a:off x="685800" y="2148840"/>
-            <a:ext cx="1965960" cy="2423160"/>
+            <a:off x="502920" y="2148840"/>
+            <a:ext cx="1664208" cy="2423160"/>
           </a:xfrm>
           <a:prstGeom prst="roundRect">
             <a:avLst/>
@@ -6462,7 +6462,7 @@
         </p:nvSpPr>
         <p:spPr>
           <a:xfrm>
-            <a:off x="1307592" y="2450592"/>
+            <a:off x="978408" y="2450592"/>
             <a:ext cx="713232" cy="713232"/>
           </a:xfrm>
           <a:prstGeom prst="ellipse">
@@ -6505,7 +6505,7 @@
         </p:nvSpPr>
         <p:spPr>
           <a:xfrm>
-            <a:off x="1307592" y="2624328"/>
+            <a:off x="978408" y="2624328"/>
             <a:ext cx="713232" cy="256032"/>
           </a:xfrm>
           <a:prstGeom prst="rect">
@@ -6540,8 +6540,8 @@
         </p:nvSpPr>
         <p:spPr>
           <a:xfrm>
-            <a:off x="850392" y="3383280"/>
-            <a:ext cx="1645920" cy="320040"/>
+            <a:off x="603504" y="3383280"/>
+            <a:ext cx="1463040" cy="320040"/>
           </a:xfrm>
           <a:prstGeom prst="rect">
             <a:avLst/>
@@ -6556,7 +6556,7 @@
           <a:p>
             <a:pPr algn="ctr"/>
             <a:r>
-              <a:rPr sz="1600" b="1">
+              <a:rPr sz="1500" b="1">
                 <a:solidFill>
                   <a:srgbClr val="0F172A"/>
                 </a:solidFill>
@@ -6575,8 +6575,8 @@
         </p:nvSpPr>
         <p:spPr>
           <a:xfrm>
-            <a:off x="850392" y="3822191"/>
-            <a:ext cx="1645920" cy="530352"/>
+            <a:off x="603504" y="3822191"/>
+            <a:ext cx="1463040" cy="530352"/>
           </a:xfrm>
           <a:prstGeom prst="rect">
             <a:avLst/>
@@ -6591,7 +6591,7 @@
           <a:p>
             <a:pPr algn="ctr"/>
             <a:r>
-              <a:rPr sz="1100" b="0">
+              <a:rPr sz="1000" b="0">
                 <a:solidFill>
                   <a:srgbClr val="475569"/>
                 </a:solidFill>
@@ -6610,8 +6610,8 @@
         </p:nvSpPr>
         <p:spPr>
           <a:xfrm>
-            <a:off x="2670048" y="2953512"/>
-            <a:ext cx="274320" cy="320040"/>
+            <a:off x="2185416" y="2953512"/>
+            <a:ext cx="228600" cy="320040"/>
           </a:xfrm>
           <a:prstGeom prst="chevron">
             <a:avLst/>
@@ -6653,8 +6653,8 @@
         </p:nvSpPr>
         <p:spPr>
           <a:xfrm>
-            <a:off x="2953512" y="2148840"/>
-            <a:ext cx="1965960" cy="2423160"/>
+            <a:off x="2441448" y="2148840"/>
+            <a:ext cx="1664208" cy="2423160"/>
           </a:xfrm>
           <a:prstGeom prst="roundRect">
             <a:avLst/>
@@ -6698,7 +6698,7 @@
         </p:nvSpPr>
         <p:spPr>
           <a:xfrm>
-            <a:off x="3575304" y="2450592"/>
+            <a:off x="2916936" y="2450592"/>
             <a:ext cx="713232" cy="713232"/>
           </a:xfrm>
           <a:prstGeom prst="ellipse">
@@ -6741,7 +6741,7 @@
         </p:nvSpPr>
         <p:spPr>
           <a:xfrm>
-            <a:off x="3575304" y="2624328"/>
+            <a:off x="2916936" y="2624328"/>
             <a:ext cx="713232" cy="256032"/>
           </a:xfrm>
           <a:prstGeom prst="rect">
@@ -6776,8 +6776,8 @@
         </p:nvSpPr>
         <p:spPr>
           <a:xfrm>
-            <a:off x="3118104" y="3383280"/>
-            <a:ext cx="1645920" cy="320040"/>
+            <a:off x="2542032" y="3383280"/>
+            <a:ext cx="1463040" cy="320040"/>
           </a:xfrm>
           <a:prstGeom prst="rect">
             <a:avLst/>
@@ -6792,7 +6792,7 @@
           <a:p>
             <a:pPr algn="ctr"/>
             <a:r>
-              <a:rPr sz="1600" b="1">
+              <a:rPr sz="1500" b="1">
                 <a:solidFill>
                   <a:srgbClr val="0F172A"/>
                 </a:solidFill>
@@ -6811,8 +6811,8 @@
         </p:nvSpPr>
         <p:spPr>
           <a:xfrm>
-            <a:off x="3118104" y="3822191"/>
-            <a:ext cx="1645920" cy="530352"/>
+            <a:off x="2542032" y="3822191"/>
+            <a:ext cx="1463040" cy="530352"/>
           </a:xfrm>
           <a:prstGeom prst="rect">
             <a:avLst/>
@@ -6827,7 +6827,7 @@
           <a:p>
             <a:pPr algn="ctr"/>
             <a:r>
-              <a:rPr sz="1100" b="0">
+              <a:rPr sz="1000" b="0">
                 <a:solidFill>
                   <a:srgbClr val="475569"/>
                 </a:solidFill>
@@ -6846,8 +6846,8 @@
         </p:nvSpPr>
         <p:spPr>
           <a:xfrm>
-            <a:off x="4937760" y="2953512"/>
-            <a:ext cx="274320" cy="320040"/>
+            <a:off x="4123944" y="2953512"/>
+            <a:ext cx="228600" cy="320040"/>
           </a:xfrm>
           <a:prstGeom prst="chevron">
             <a:avLst/>
@@ -6889,8 +6889,8 @@
         </p:nvSpPr>
         <p:spPr>
           <a:xfrm>
-            <a:off x="5221224" y="2148840"/>
-            <a:ext cx="1965960" cy="2423160"/>
+            <a:off x="4379976" y="2148840"/>
+            <a:ext cx="1664208" cy="2423160"/>
           </a:xfrm>
           <a:prstGeom prst="roundRect">
             <a:avLst/>
@@ -6934,7 +6934,7 @@
         </p:nvSpPr>
         <p:spPr>
           <a:xfrm>
-            <a:off x="5843016" y="2450592"/>
+            <a:off x="4855464" y="2450592"/>
             <a:ext cx="713232" cy="713232"/>
           </a:xfrm>
           <a:prstGeom prst="ellipse">
@@ -6977,7 +6977,7 @@
         </p:nvSpPr>
         <p:spPr>
           <a:xfrm>
-            <a:off x="5843016" y="2624328"/>
+            <a:off x="4855464" y="2624328"/>
             <a:ext cx="713232" cy="256032"/>
           </a:xfrm>
           <a:prstGeom prst="rect">
@@ -7012,8 +7012,8 @@
         </p:nvSpPr>
         <p:spPr>
           <a:xfrm>
-            <a:off x="5385816" y="3383280"/>
-            <a:ext cx="1645920" cy="320040"/>
+            <a:off x="4480560" y="3383280"/>
+            <a:ext cx="1463040" cy="320040"/>
           </a:xfrm>
           <a:prstGeom prst="rect">
             <a:avLst/>
@@ -7028,13 +7028,13 @@
           <a:p>
             <a:pPr algn="ctr"/>
             <a:r>
-              <a:rPr sz="1600" b="1">
+              <a:rPr sz="1500" b="1">
                 <a:solidFill>
                   <a:srgbClr val="0F172A"/>
                 </a:solidFill>
                 <a:latin typeface="Aptos"/>
               </a:rPr>
-              <a:t>Jadwal</a:t>
+              <a:t>Data</a:t>
             </a:r>
           </a:p>
         </p:txBody>
@@ -7047,8 +7047,8 @@
         </p:nvSpPr>
         <p:spPr>
           <a:xfrm>
-            <a:off x="5385816" y="3822191"/>
-            <a:ext cx="1645920" cy="530352"/>
+            <a:off x="4480560" y="3822191"/>
+            <a:ext cx="1463040" cy="530352"/>
           </a:xfrm>
           <a:prstGeom prst="rect">
             <a:avLst/>
@@ -7063,13 +7063,13 @@
           <a:p>
             <a:pPr algn="ctr"/>
             <a:r>
-              <a:rPr sz="1100" b="0">
+              <a:rPr sz="1000" b="0">
                 <a:solidFill>
                   <a:srgbClr val="475569"/>
                 </a:solidFill>
                 <a:latin typeface="Aptos"/>
               </a:rPr>
-              <a:t>Tunjukkan filter dan validasi bentrok.</a:t>
+              <a:t>Tunjukkan anggota kelas dan urutan jam.</a:t>
             </a:r>
           </a:p>
         </p:txBody>
@@ -7082,8 +7082,8 @@
         </p:nvSpPr>
         <p:spPr>
           <a:xfrm>
-            <a:off x="7205472" y="2953512"/>
-            <a:ext cx="274320" cy="320040"/>
+            <a:off x="6062472" y="2953512"/>
+            <a:ext cx="228600" cy="320040"/>
           </a:xfrm>
           <a:prstGeom prst="chevron">
             <a:avLst/>
@@ -7125,8 +7125,8 @@
         </p:nvSpPr>
         <p:spPr>
           <a:xfrm>
-            <a:off x="7488936" y="2148840"/>
-            <a:ext cx="1965960" cy="2423160"/>
+            <a:off x="6318504" y="2148840"/>
+            <a:ext cx="1664208" cy="2423160"/>
           </a:xfrm>
           <a:prstGeom prst="roundRect">
             <a:avLst/>
@@ -7170,7 +7170,7 @@
         </p:nvSpPr>
         <p:spPr>
           <a:xfrm>
-            <a:off x="8110727" y="2450592"/>
+            <a:off x="6793992" y="2450592"/>
             <a:ext cx="713232" cy="713232"/>
           </a:xfrm>
           <a:prstGeom prst="ellipse">
@@ -7213,7 +7213,7 @@
         </p:nvSpPr>
         <p:spPr>
           <a:xfrm>
-            <a:off x="8110727" y="2624328"/>
+            <a:off x="6793992" y="2624328"/>
             <a:ext cx="713232" cy="256032"/>
           </a:xfrm>
           <a:prstGeom prst="rect">
@@ -7248,8 +7248,8 @@
         </p:nvSpPr>
         <p:spPr>
           <a:xfrm>
-            <a:off x="7653527" y="3383280"/>
-            <a:ext cx="1645920" cy="320040"/>
+            <a:off x="6419088" y="3383280"/>
+            <a:ext cx="1463040" cy="320040"/>
           </a:xfrm>
           <a:prstGeom prst="rect">
             <a:avLst/>
@@ -7264,13 +7264,13 @@
           <a:p>
             <a:pPr algn="ctr"/>
             <a:r>
-              <a:rPr sz="1600" b="1">
+              <a:rPr sz="1500" b="1">
                 <a:solidFill>
                   <a:srgbClr val="0F172A"/>
                 </a:solidFill>
                 <a:latin typeface="Aptos"/>
               </a:rPr>
-              <a:t>Nilai</a:t>
+              <a:t>Jadwal</a:t>
             </a:r>
           </a:p>
         </p:txBody>
@@ -7283,8 +7283,8 @@
         </p:nvSpPr>
         <p:spPr>
           <a:xfrm>
-            <a:off x="7653527" y="3822191"/>
-            <a:ext cx="1645920" cy="530352"/>
+            <a:off x="6419088" y="3822191"/>
+            <a:ext cx="1463040" cy="530352"/>
           </a:xfrm>
           <a:prstGeom prst="rect">
             <a:avLst/>
@@ -7299,13 +7299,13 @@
           <a:p>
             <a:pPr algn="ctr"/>
             <a:r>
-              <a:rPr sz="1100" b="0">
+              <a:rPr sz="1000" b="0">
                 <a:solidFill>
                   <a:srgbClr val="475569"/>
                 </a:solidFill>
                 <a:latin typeface="Aptos"/>
               </a:rPr>
-              <a:t>Masuk sebagai Guru dan isi nilai massal.</a:t>
+              <a:t>Tunjukkan pilihan bertingkat dan bentrok.</a:t>
             </a:r>
           </a:p>
         </p:txBody>
@@ -7318,8 +7318,8 @@
         </p:nvSpPr>
         <p:spPr>
           <a:xfrm>
-            <a:off x="9473184" y="2953512"/>
-            <a:ext cx="274320" cy="320040"/>
+            <a:off x="8001000" y="2953512"/>
+            <a:ext cx="228600" cy="320040"/>
           </a:xfrm>
           <a:prstGeom prst="chevron">
             <a:avLst/>
@@ -7361,8 +7361,8 @@
         </p:nvSpPr>
         <p:spPr>
           <a:xfrm>
-            <a:off x="9756648" y="2148840"/>
-            <a:ext cx="1965960" cy="2423160"/>
+            <a:off x="8257032" y="2148840"/>
+            <a:ext cx="1664208" cy="2423160"/>
           </a:xfrm>
           <a:prstGeom prst="roundRect">
             <a:avLst/>
@@ -7406,7 +7406,7 @@
         </p:nvSpPr>
         <p:spPr>
           <a:xfrm>
-            <a:off x="10378440" y="2450592"/>
+            <a:off x="8732520" y="2450592"/>
             <a:ext cx="713232" cy="713232"/>
           </a:xfrm>
           <a:prstGeom prst="ellipse">
@@ -7449,7 +7449,7 @@
         </p:nvSpPr>
         <p:spPr>
           <a:xfrm>
-            <a:off x="10378440" y="2624328"/>
+            <a:off x="8732520" y="2624328"/>
             <a:ext cx="713232" cy="256032"/>
           </a:xfrm>
           <a:prstGeom prst="rect">
@@ -7484,8 +7484,8 @@
         </p:nvSpPr>
         <p:spPr>
           <a:xfrm>
-            <a:off x="9921240" y="3383280"/>
-            <a:ext cx="1645920" cy="320040"/>
+            <a:off x="8357616" y="3383280"/>
+            <a:ext cx="1463040" cy="320040"/>
           </a:xfrm>
           <a:prstGeom prst="rect">
             <a:avLst/>
@@ -7500,12 +7500,248 @@
           <a:p>
             <a:pPr algn="ctr"/>
             <a:r>
-              <a:rPr sz="1600" b="1">
+              <a:rPr sz="1500" b="1">
                 <a:solidFill>
                   <a:srgbClr val="0F172A"/>
                 </a:solidFill>
                 <a:latin typeface="Aptos"/>
               </a:rPr>
+              <a:t>Nilai</a:t>
+            </a:r>
+          </a:p>
+        </p:txBody>
+      </p:sp>
+      <p:sp>
+        <p:nvSpPr>
+          <p:cNvPr id="33" name="TextBox 32"/>
+          <p:cNvSpPr txBox="1"/>
+          <p:nvPr/>
+        </p:nvSpPr>
+        <p:spPr>
+          <a:xfrm>
+            <a:off x="8357616" y="3822191"/>
+            <a:ext cx="1463040" cy="530352"/>
+          </a:xfrm>
+          <a:prstGeom prst="rect">
+            <a:avLst/>
+          </a:prstGeom>
+          <a:noFill/>
+        </p:spPr>
+        <p:txBody>
+          <a:bodyPr wrap="square" anchor="t">
+            <a:spAutoFit/>
+          </a:bodyPr>
+          <a:lstStyle/>
+          <a:p>
+            <a:pPr algn="ctr"/>
+            <a:r>
+              <a:rPr sz="1000" b="0">
+                <a:solidFill>
+                  <a:srgbClr val="475569"/>
+                </a:solidFill>
+                <a:latin typeface="Aptos"/>
+              </a:rPr>
+              <a:t>Masuk sebagai Guru dan isi nilai massal.</a:t>
+            </a:r>
+          </a:p>
+        </p:txBody>
+      </p:sp>
+      <p:sp>
+        <p:nvSpPr>
+          <p:cNvPr id="34" name="Chevron 33"/>
+          <p:cNvSpPr/>
+          <p:nvPr/>
+        </p:nvSpPr>
+        <p:spPr>
+          <a:xfrm>
+            <a:off x="9939528" y="2953512"/>
+            <a:ext cx="228600" cy="320040"/>
+          </a:xfrm>
+          <a:prstGeom prst="chevron">
+            <a:avLst/>
+          </a:prstGeom>
+          <a:solidFill>
+            <a:srgbClr val="BAE6FD"/>
+          </a:solidFill>
+          <a:ln>
+            <a:noFill/>
+          </a:ln>
+        </p:spPr>
+        <p:style>
+          <a:lnRef idx="1">
+            <a:schemeClr val="accent1"/>
+          </a:lnRef>
+          <a:fillRef idx="3">
+            <a:schemeClr val="accent1"/>
+          </a:fillRef>
+          <a:effectRef idx="2">
+            <a:schemeClr val="accent1"/>
+          </a:effectRef>
+          <a:fontRef idx="minor">
+            <a:schemeClr val="lt1"/>
+          </a:fontRef>
+        </p:style>
+        <p:txBody>
+          <a:bodyPr rtlCol="0" anchor="ctr"/>
+          <a:lstStyle/>
+          <a:p>
+            <a:pPr algn="ctr"/>
+          </a:p>
+        </p:txBody>
+      </p:sp>
+      <p:sp>
+        <p:nvSpPr>
+          <p:cNvPr id="35" name="Rounded Rectangle 34"/>
+          <p:cNvSpPr/>
+          <p:nvPr/>
+        </p:nvSpPr>
+        <p:spPr>
+          <a:xfrm>
+            <a:off x="10195560" y="2148840"/>
+            <a:ext cx="1664208" cy="2423160"/>
+          </a:xfrm>
+          <a:prstGeom prst="roundRect">
+            <a:avLst/>
+          </a:prstGeom>
+          <a:solidFill>
+            <a:srgbClr val="FFFFFF"/>
+          </a:solidFill>
+          <a:ln w="12700">
+            <a:solidFill>
+              <a:srgbClr val="E2E8F0"/>
+            </a:solidFill>
+          </a:ln>
+        </p:spPr>
+        <p:style>
+          <a:lnRef idx="1">
+            <a:schemeClr val="accent1"/>
+          </a:lnRef>
+          <a:fillRef idx="3">
+            <a:schemeClr val="accent1"/>
+          </a:fillRef>
+          <a:effectRef idx="2">
+            <a:schemeClr val="accent1"/>
+          </a:effectRef>
+          <a:fontRef idx="minor">
+            <a:schemeClr val="lt1"/>
+          </a:fontRef>
+        </p:style>
+        <p:txBody>
+          <a:bodyPr rtlCol="0" anchor="ctr"/>
+          <a:lstStyle/>
+          <a:p>
+            <a:pPr algn="ctr"/>
+          </a:p>
+        </p:txBody>
+      </p:sp>
+      <p:sp>
+        <p:nvSpPr>
+          <p:cNvPr id="36" name="Oval 35"/>
+          <p:cNvSpPr/>
+          <p:nvPr/>
+        </p:nvSpPr>
+        <p:spPr>
+          <a:xfrm>
+            <a:off x="10671048" y="2450592"/>
+            <a:ext cx="713232" cy="713232"/>
+          </a:xfrm>
+          <a:prstGeom prst="ellipse">
+            <a:avLst/>
+          </a:prstGeom>
+          <a:solidFill>
+            <a:srgbClr val="0284C7"/>
+          </a:solidFill>
+          <a:ln>
+            <a:noFill/>
+          </a:ln>
+        </p:spPr>
+        <p:style>
+          <a:lnRef idx="1">
+            <a:schemeClr val="accent1"/>
+          </a:lnRef>
+          <a:fillRef idx="3">
+            <a:schemeClr val="accent1"/>
+          </a:fillRef>
+          <a:effectRef idx="2">
+            <a:schemeClr val="accent1"/>
+          </a:effectRef>
+          <a:fontRef idx="minor">
+            <a:schemeClr val="lt1"/>
+          </a:fontRef>
+        </p:style>
+        <p:txBody>
+          <a:bodyPr rtlCol="0" anchor="ctr"/>
+          <a:lstStyle/>
+          <a:p>
+            <a:pPr algn="ctr"/>
+          </a:p>
+        </p:txBody>
+      </p:sp>
+      <p:sp>
+        <p:nvSpPr>
+          <p:cNvPr id="37" name="TextBox 36"/>
+          <p:cNvSpPr txBox="1"/>
+          <p:nvPr/>
+        </p:nvSpPr>
+        <p:spPr>
+          <a:xfrm>
+            <a:off x="10671048" y="2624328"/>
+            <a:ext cx="713232" cy="256032"/>
+          </a:xfrm>
+          <a:prstGeom prst="rect">
+            <a:avLst/>
+          </a:prstGeom>
+          <a:noFill/>
+        </p:spPr>
+        <p:txBody>
+          <a:bodyPr wrap="square" anchor="t">
+            <a:spAutoFit/>
+          </a:bodyPr>
+          <a:lstStyle/>
+          <a:p>
+            <a:pPr algn="ctr"/>
+            <a:r>
+              <a:rPr sz="1800" b="1">
+                <a:solidFill>
+                  <a:srgbClr val="FFFFFF"/>
+                </a:solidFill>
+                <a:latin typeface="Aptos"/>
+              </a:rPr>
+              <a:t>6</a:t>
+            </a:r>
+          </a:p>
+        </p:txBody>
+      </p:sp>
+      <p:sp>
+        <p:nvSpPr>
+          <p:cNvPr id="38" name="TextBox 37"/>
+          <p:cNvSpPr txBox="1"/>
+          <p:nvPr/>
+        </p:nvSpPr>
+        <p:spPr>
+          <a:xfrm>
+            <a:off x="10296144" y="3383280"/>
+            <a:ext cx="1463040" cy="320040"/>
+          </a:xfrm>
+          <a:prstGeom prst="rect">
+            <a:avLst/>
+          </a:prstGeom>
+          <a:noFill/>
+        </p:spPr>
+        <p:txBody>
+          <a:bodyPr wrap="square" anchor="t">
+            <a:spAutoFit/>
+          </a:bodyPr>
+          <a:lstStyle/>
+          <a:p>
+            <a:pPr algn="ctr"/>
+            <a:r>
+              <a:rPr sz="1500" b="1">
+                <a:solidFill>
+                  <a:srgbClr val="0F172A"/>
+                </a:solidFill>
+                <a:latin typeface="Aptos"/>
+              </a:rPr>
               <a:t>Hasil</a:t>
             </a:r>
           </a:p>
@@ -7513,14 +7749,14 @@
       </p:sp>
       <p:sp>
         <p:nvSpPr>
-          <p:cNvPr id="33" name="TextBox 32"/>
-          <p:cNvSpPr txBox="1"/>
-          <p:nvPr/>
-        </p:nvSpPr>
-        <p:spPr>
-          <a:xfrm>
-            <a:off x="9921240" y="3822191"/>
-            <a:ext cx="1645920" cy="530352"/>
+          <p:cNvPr id="39" name="TextBox 38"/>
+          <p:cNvSpPr txBox="1"/>
+          <p:nvPr/>
+        </p:nvSpPr>
+        <p:spPr>
+          <a:xfrm>
+            <a:off x="10296144" y="3822191"/>
+            <a:ext cx="1463040" cy="530352"/>
           </a:xfrm>
           <a:prstGeom prst="rect">
             <a:avLst/>
@@ -7535,20 +7771,20 @@
           <a:p>
             <a:pPr algn="ctr"/>
             <a:r>
-              <a:rPr sz="1100" b="0">
+              <a:rPr sz="1000" b="0">
                 <a:solidFill>
                   <a:srgbClr val="475569"/>
                 </a:solidFill>
                 <a:latin typeface="Aptos"/>
               </a:rPr>
-              <a:t>Masuk sebagai Siswa, lalu buka laporan PDF.</a:t>
-            </a:r>
-          </a:p>
-        </p:txBody>
-      </p:sp>
-      <p:sp>
-        <p:nvSpPr>
-          <p:cNvPr id="34" name="Rounded Rectangle 33"/>
+              <a:t>Buka Nilai Saya dan laporan PDF.</a:t>
+            </a:r>
+          </a:p>
+        </p:txBody>
+      </p:sp>
+      <p:sp>
+        <p:nvSpPr>
+          <p:cNvPr id="40" name="Rounded Rectangle 39"/>
           <p:cNvSpPr/>
           <p:nvPr/>
         </p:nvSpPr>
@@ -7593,7 +7829,7 @@
       </p:sp>
       <p:sp>
         <p:nvSpPr>
-          <p:cNvPr id="35" name="TextBox 34"/>
+          <p:cNvPr id="41" name="TextBox 40"/>
           <p:cNvSpPr txBox="1"/>
           <p:nvPr/>
         </p:nvSpPr>
@@ -7628,7 +7864,7 @@
       </p:sp>
       <p:sp>
         <p:nvSpPr>
-          <p:cNvPr id="36" name="TextBox 35"/>
+          <p:cNvPr id="42" name="TextBox 41"/>
           <p:cNvSpPr txBox="1"/>
           <p:nvPr/>
         </p:nvSpPr>
@@ -7663,7 +7899,7 @@
       </p:sp>
       <p:sp>
         <p:nvSpPr>
-          <p:cNvPr id="37" name="TextBox 36"/>
+          <p:cNvPr id="43" name="TextBox 42"/>
           <p:cNvSpPr txBox="1"/>
           <p:nvPr/>
         </p:nvSpPr>
@@ -8950,8 +9186,8 @@
         </p:blipFill>
         <p:spPr>
           <a:xfrm>
-            <a:off x="1035556" y="2011680"/>
-            <a:ext cx="4009647" cy="3639312"/>
+            <a:off x="2040263" y="2011680"/>
+            <a:ext cx="2000232" cy="3639312"/>
           </a:xfrm>
           <a:prstGeom prst="rect">
             <a:avLst/>
@@ -11073,8 +11309,8 @@
         </p:blipFill>
         <p:spPr>
           <a:xfrm>
-            <a:off x="2071217" y="1920240"/>
-            <a:ext cx="4452925" cy="4041648"/>
+            <a:off x="3186998" y="1920240"/>
+            <a:ext cx="2221363" cy="4041648"/>
           </a:xfrm>
           <a:prstGeom prst="rect">
             <a:avLst/>
@@ -11124,7 +11360,7 @@
                 </a:solidFill>
                 <a:latin typeface="Aptos"/>
               </a:rPr>
-              <a:t>guru, siswa, kelas, mata pelajaran, jadwal, dan nilai.</a:t>
+              <a:t>guru, siswa, kelas, mata pelajaran, pengajaran, dan jadwal.</a:t>
             </a:r>
           </a:p>
           <a:p>
@@ -11165,7 +11401,7 @@
                 </a:solidFill>
                 <a:latin typeface="Aptos"/>
               </a:rPr>
-              <a:t>Jadwal hari ini - </a:t>
+              <a:t>Status akademik - </a:t>
             </a:r>
             <a:r>
               <a:rPr sz="1600">
@@ -11174,7 +11410,7 @@
                 </a:solidFill>
                 <a:latin typeface="Aptos"/>
               </a:rPr>
-              <a:t>informasi kegiatan akademik terbaru.</a:t>
+              <a:t>progres nilai, penempatan siswa, dan kegiatan hari ini.</a:t>
             </a:r>
           </a:p>
         </p:txBody>
@@ -12542,7 +12778,7 @@
                 </a:solidFill>
                 <a:latin typeface="Aptos"/>
               </a:rPr>
-              <a:t>Pencarian dan filter</a:t>
+              <a:t>Tabel modern</a:t>
             </a:r>
           </a:p>
         </p:txBody>
@@ -12556,7 +12792,7 @@
         <p:spPr>
           <a:xfrm>
             <a:off x="6629400" y="4910328"/>
-            <a:ext cx="4526280" cy="384048"/>
+            <a:ext cx="4526280" cy="457200"/>
           </a:xfrm>
           <a:prstGeom prst="rect">
             <a:avLst/>
@@ -12577,7 +12813,7 @@
                 </a:solidFill>
                 <a:latin typeface="Aptos"/>
               </a:rPr>
-              <a:t>Tabel dapat dicari, diurutkan, disaring, dan dibagi per halaman.</a:t>
+              <a:t>Search, filter, sorting, bulk action, URL state, dan urutan jam drag-and-drop.</a:t>
             </a:r>
           </a:p>
         </p:txBody>
@@ -12861,8 +13097,8 @@
         </p:blipFill>
         <p:spPr>
           <a:xfrm>
-            <a:off x="1386485" y="1920240"/>
-            <a:ext cx="5639508" cy="4041648"/>
+            <a:off x="2061813" y="1920240"/>
+            <a:ext cx="4288852" cy="4041648"/>
           </a:xfrm>
           <a:prstGeom prst="rect">
             <a:avLst/>
@@ -13598,8 +13834,8 @@
         </p:blipFill>
         <p:spPr>
           <a:xfrm>
-            <a:off x="1547713" y="1920240"/>
-            <a:ext cx="5819973" cy="4041648"/>
+            <a:off x="1916227" y="1920240"/>
+            <a:ext cx="5082945" cy="4041648"/>
           </a:xfrm>
           <a:prstGeom prst="rect">
             <a:avLst/>

</xml_diff>